<commit_message>
Finaliza relatorios, slides e Post-Mortem
</commit_message>
<xml_diff>
--- a/Cloud Computing & Cloud Storages/Cloud_Computing_AWS_Slides.pptx
+++ b/Cloud Computing & Cloud Storages/Cloud_Computing_AWS_Slides.pptx
@@ -8550,7 +8550,7 @@
               </a:defRPr>
             </a:pPr>
             <a:r>
-              <a:t>Pendência</a:t>
+              <a:t>Consolidação</a:t>
             </a:r>
           </a:p>
         </p:txBody>
@@ -8586,7 +8586,7 @@
               </a:defRPr>
             </a:pPr>
             <a:r>
-              <a:t>Confirmar Grupo 3/7 e divisão humana real.</a:t>
+              <a:t>Raphael coordenou a consolidação em 06/09; o Codex conferiu os artefatos e a divisão final foi registrada.</a:t>
             </a:r>
           </a:p>
         </p:txBody>

</xml_diff>